<commit_message>
Persingkat headline dan ubah ke register akademis
Headline sebelumnya berbentuk kalimat penuh dengan nada percakapan, misalnya
"Etika Bisnis Butuh Dasar, Bukan Selera" dan "Yang Dapat Dibawa Pulang
Manajer". Seluruhnya diganti menjadi frasa nominal yang lebih pendek:
"Urgensi Teori Etika Normatif", "Implikasi Manajerial", dan seterusnya.

Pada deck kasus, tiga slide analisis kini memakai judul paralel: Penilaian
Berbasis Akibat, Berbasis Prinsip, dan Berbasis Konteks.

Keterangan yang hilang dari headline dipindahkan ke pill, misalnya nama
Immanuel Kant, John Rawls, dan Producing Toys, sehingga tidak ada informasi
yang gugur. Pill yang menjadi berulang dengan headline barunya diganti.

Beberapa label kartu yang berada tepat di bawah headline ikut disesuaikan
agar registernya seragam. Terminologi buku yang berbahasa Inggris tetap
dipertahankan apa adanya.

Co-Authored-By: Claude Opus 5 <noreply@anthropic.com>
Claude-Session: https://claude.ai/code/session_01XhxnFZQSR9cgT9Xb7YLA6R
</commit_message>
<xml_diff>
--- a/business-ethics/chapter-3/decks/Deck-1-Evaluating-Business-Ethics.pptx
+++ b/business-ethics/chapter-3/decks/Deck-1-Evaluating-Business-Ethics.pptx
@@ -4294,7 +4294,7 @@
         <p:spPr>
           <a:xfrm>
             <a:off x="1794053" y="457200"/>
-            <a:ext cx="1687068" cy="283464"/>
+            <a:ext cx="1506017" cy="283464"/>
           </a:xfrm>
           <a:prstGeom prst="roundRect">
             <a:avLst>
@@ -4321,7 +4321,7 @@
         <p:spPr>
           <a:xfrm>
             <a:off x="1794053" y="457200"/>
-            <a:ext cx="1687068" cy="283464"/>
+            <a:ext cx="1506017" cy="283464"/>
           </a:xfrm>
           <a:prstGeom prst="rect">
             <a:avLst/>
@@ -4345,7 +4345,7 @@
                 <a:ea typeface="Calibri" pitchFamily="34" charset="-122"/>
                 <a:cs typeface="Calibri" pitchFamily="34" charset="-120"/>
               </a:rPr>
-              <a:t>PRINCIPLE-BASED</a:t>
+              <a:t>IMMANUEL KANT</a:t>
             </a:r>
             <a:endParaRPr lang="en-US" sz="950" dirty="0"/>
           </a:p>
@@ -4426,7 +4426,7 @@
                 <a:ea typeface="Calibri" pitchFamily="34" charset="-122"/>
                 <a:cs typeface="Calibri" pitchFamily="34" charset="-120"/>
               </a:rPr>
-              <a:t>Ethics of Duties: Immanuel Kant</a:t>
+              <a:t>Ethics of Duties</a:t>
             </a:r>
             <a:pPr indent="0" marL="0">
               <a:lnSpc>
@@ -5427,7 +5427,7 @@
         <p:spPr>
           <a:xfrm>
             <a:off x="1794053" y="457200"/>
-            <a:ext cx="1687068" cy="283464"/>
+            <a:ext cx="1868119" cy="283464"/>
           </a:xfrm>
           <a:prstGeom prst="roundRect">
             <a:avLst>
@@ -5454,7 +5454,7 @@
         <p:spPr>
           <a:xfrm>
             <a:off x="1794053" y="457200"/>
-            <a:ext cx="1687068" cy="283464"/>
+            <a:ext cx="1868119" cy="283464"/>
           </a:xfrm>
           <a:prstGeom prst="rect">
             <a:avLst/>
@@ -5478,7 +5478,7 @@
                 <a:ea typeface="Calibri" pitchFamily="34" charset="-122"/>
                 <a:cs typeface="Calibri" pitchFamily="34" charset="-120"/>
               </a:rPr>
-              <a:t>PRINCIPLE-BASED</a:t>
+              <a:t>HAK ASASI MANUSIA</a:t>
             </a:r>
             <a:endParaRPr lang="en-US" sz="950" dirty="0"/>
           </a:p>
@@ -5559,7 +5559,7 @@
                 <a:ea typeface="Calibri" pitchFamily="34" charset="-122"/>
                 <a:cs typeface="Calibri" pitchFamily="34" charset="-120"/>
               </a:rPr>
-              <a:t>Ethics of Rights: Hak Asasi Manusia</a:t>
+              <a:t>Ethics of Rights</a:t>
             </a:r>
             <a:pPr indent="0" marL="0">
               <a:lnSpc>
@@ -6759,7 +6759,7 @@
         <p:spPr>
           <a:xfrm>
             <a:off x="1794053" y="457200"/>
-            <a:ext cx="1687068" cy="283464"/>
+            <a:ext cx="1234440" cy="283464"/>
           </a:xfrm>
           <a:prstGeom prst="roundRect">
             <a:avLst>
@@ -6786,7 +6786,7 @@
         <p:spPr>
           <a:xfrm>
             <a:off x="1794053" y="457200"/>
-            <a:ext cx="1687068" cy="283464"/>
+            <a:ext cx="1234440" cy="283464"/>
           </a:xfrm>
           <a:prstGeom prst="rect">
             <a:avLst/>
@@ -6810,7 +6810,7 @@
                 <a:ea typeface="Calibri" pitchFamily="34" charset="-122"/>
                 <a:cs typeface="Calibri" pitchFamily="34" charset="-120"/>
               </a:rPr>
-              <a:t>PRINCIPLE-BASED</a:t>
+              <a:t>JOHN RAWLS</a:t>
             </a:r>
             <a:endParaRPr lang="en-US" sz="950" dirty="0"/>
           </a:p>
@@ -6891,7 +6891,7 @@
                 <a:ea typeface="Calibri" pitchFamily="34" charset="-122"/>
                 <a:cs typeface="Calibri" pitchFamily="34" charset="-120"/>
               </a:rPr>
-              <a:t>Justice: John Rawls</a:t>
+              <a:t>Theory of Justice</a:t>
             </a:r>
             <a:pPr indent="0" marL="0">
               <a:lnSpc>
@@ -7565,7 +7565,7 @@
         <p:spPr>
           <a:xfrm>
             <a:off x="621792" y="457200"/>
-            <a:ext cx="1868119" cy="283464"/>
+            <a:ext cx="1324966" cy="283464"/>
           </a:xfrm>
           <a:prstGeom prst="roundRect">
             <a:avLst>
@@ -7592,7 +7592,7 @@
         <p:spPr>
           <a:xfrm>
             <a:off x="621792" y="457200"/>
-            <a:ext cx="1868119" cy="283464"/>
+            <a:ext cx="1324966" cy="283464"/>
           </a:xfrm>
           <a:prstGeom prst="rect">
             <a:avLst/>
@@ -7616,7 +7616,7 @@
                 <a:ea typeface="Calibri" pitchFamily="34" charset="-122"/>
                 <a:cs typeface="Calibri" pitchFamily="34" charset="-120"/>
               </a:rPr>
-              <a:t>BATAS TEORI BARAT</a:t>
+              <a:t>ENAM KRITIK</a:t>
             </a:r>
             <a:endParaRPr lang="en-US" sz="950" dirty="0"/>
           </a:p>
@@ -7630,7 +7630,7 @@
         </p:nvSpPr>
         <p:spPr>
           <a:xfrm>
-            <a:off x="2608783" y="457200"/>
+            <a:off x="2065630" y="457200"/>
             <a:ext cx="1324966" cy="283464"/>
           </a:xfrm>
           <a:prstGeom prst="roundRect">
@@ -7657,7 +7657,7 @@
         </p:nvSpPr>
         <p:spPr>
           <a:xfrm>
-            <a:off x="2608783" y="457200"/>
+            <a:off x="2065630" y="457200"/>
             <a:ext cx="1324966" cy="283464"/>
           </a:xfrm>
           <a:prstGeom prst="rect">
@@ -7763,7 +7763,7 @@
                 <a:ea typeface="Calibri" pitchFamily="34" charset="-122"/>
                 <a:cs typeface="Calibri" pitchFamily="34" charset="-120"/>
               </a:rPr>
-              <a:t>Enam Kritik terhadap Teori Barat Modern</a:t>
+              <a:t>Kritik atas Teori Barat Modern</a:t>
             </a:r>
             <a:pPr indent="0" marL="0">
               <a:lnSpc>
@@ -9065,7 +9065,7 @@
         <p:spPr>
           <a:xfrm>
             <a:off x="621792" y="457200"/>
-            <a:ext cx="1234440" cy="283464"/>
+            <a:ext cx="1777594" cy="283464"/>
           </a:xfrm>
           <a:prstGeom prst="roundRect">
             <a:avLst>
@@ -9092,7 +9092,7 @@
         <p:spPr>
           <a:xfrm>
             <a:off x="621792" y="457200"/>
-            <a:ext cx="1234440" cy="283464"/>
+            <a:ext cx="1777594" cy="283464"/>
           </a:xfrm>
           <a:prstGeom prst="rect">
             <a:avLst/>
@@ -9116,7 +9116,7 @@
                 <a:ea typeface="Calibri" pitchFamily="34" charset="-122"/>
                 <a:cs typeface="Calibri" pitchFamily="34" charset="-120"/>
               </a:rPr>
-              <a:t>ALTERNATIF</a:t>
+              <a:t>EMPAT ALTERNATIF</a:t>
             </a:r>
             <a:endParaRPr lang="en-US" sz="950" dirty="0"/>
           </a:p>
@@ -9130,7 +9130,7 @@
         </p:nvSpPr>
         <p:spPr>
           <a:xfrm>
-            <a:off x="1975104" y="457200"/>
+            <a:off x="2518258" y="457200"/>
             <a:ext cx="1687068" cy="283464"/>
           </a:xfrm>
           <a:prstGeom prst="roundRect">
@@ -9157,7 +9157,7 @@
         </p:nvSpPr>
         <p:spPr>
           <a:xfrm>
-            <a:off x="1975104" y="457200"/>
+            <a:off x="2518258" y="457200"/>
             <a:ext cx="1687068" cy="283464"/>
           </a:xfrm>
           <a:prstGeom prst="rect">
@@ -9263,7 +9263,7 @@
                 <a:ea typeface="Calibri" pitchFamily="34" charset="-122"/>
                 <a:cs typeface="Calibri" pitchFamily="34" charset="-120"/>
               </a:rPr>
-              <a:t>Empat Perspektif Alternatif</a:t>
+              <a:t>Perspektif Alternatif</a:t>
             </a:r>
             <a:pPr indent="0" marL="0">
               <a:lnSpc>
@@ -9322,7 +9322,7 @@
                 <a:ea typeface="Calibri" pitchFamily="34" charset="-122"/>
                 <a:cs typeface="Calibri" pitchFamily="34" charset="-120"/>
               </a:rPr>
-              <a:t>Lebih fleksibel, lebih memperhatikan pengambil keputusan, konteks, dan relasinya.</a:t>
+              <a:t>Menekankan fleksibilitas serta konteks dan relasi pengambil keputusan.</a:t>
             </a:r>
             <a:endParaRPr lang="en-US" sz="1350" dirty="0"/>
           </a:p>
@@ -12894,7 +12894,7 @@
                 <a:ea typeface="Calibri" pitchFamily="34" charset="-122"/>
                 <a:cs typeface="Calibri" pitchFamily="34" charset="-120"/>
               </a:rPr>
-              <a:t>Angka dari Kedua Sisi Sama Besarnya</a:t>
+              <a:t>Manfaat Ekonomi dan Biaya Ekologis</a:t>
             </a:r>
             <a:pPr indent="0" marL="0">
               <a:lnSpc>
@@ -13443,7 +13443,7 @@
                 <a:ea typeface="Calibri" pitchFamily="34" charset="-122"/>
                 <a:cs typeface="Calibri" pitchFamily="34" charset="-120"/>
               </a:rPr>
-              <a:t>Yang Dihitung Pendukung</a:t>
+              <a:t>Perhitungan Pendukung</a:t>
             </a:r>
             <a:endParaRPr lang="en-US" sz="1600" dirty="0"/>
           </a:p>
@@ -13609,7 +13609,7 @@
                 <a:ea typeface="Calibri" pitchFamily="34" charset="-122"/>
                 <a:cs typeface="Calibri" pitchFamily="34" charset="-120"/>
               </a:rPr>
-              <a:t>Yang Dihitung Penentang</a:t>
+              <a:t>Perhitungan Penentang</a:t>
             </a:r>
             <a:endParaRPr lang="en-US" sz="1600" dirty="0"/>
           </a:p>
@@ -13908,7 +13908,7 @@
         <p:spPr>
           <a:xfrm>
             <a:off x="1522476" y="457200"/>
-            <a:ext cx="1234440" cy="283464"/>
+            <a:ext cx="1958645" cy="283464"/>
           </a:xfrm>
           <a:prstGeom prst="roundRect">
             <a:avLst>
@@ -13935,7 +13935,7 @@
         <p:spPr>
           <a:xfrm>
             <a:off x="1522476" y="457200"/>
-            <a:ext cx="1234440" cy="283464"/>
+            <a:ext cx="1958645" cy="283464"/>
           </a:xfrm>
           <a:prstGeom prst="rect">
             <a:avLst/>
@@ -13959,7 +13959,7 @@
                 <a:ea typeface="Calibri" pitchFamily="34" charset="-122"/>
                 <a:cs typeface="Calibri" pitchFamily="34" charset="-120"/>
               </a:rPr>
-              <a:t>DUA NARASI</a:t>
+              <a:t>KLAIM DAN BANTAHAN</a:t>
             </a:r>
             <a:endParaRPr lang="en-US" sz="950" dirty="0"/>
           </a:p>
@@ -14040,7 +14040,7 @@
                 <a:ea typeface="Calibri" pitchFamily="34" charset="-122"/>
                 <a:cs typeface="Calibri" pitchFamily="34" charset="-120"/>
               </a:rPr>
-              <a:t>Ethical Oil dan Bantahannya</a:t>
+              <a:t>Klaim Ethical Oil</a:t>
             </a:r>
             <a:pPr indent="0" marL="0">
               <a:lnSpc>
@@ -15363,7 +15363,7 @@
                 <a:ea typeface="Calibri" pitchFamily="34" charset="-122"/>
                 <a:cs typeface="Calibri" pitchFamily="34" charset="-120"/>
               </a:rPr>
-              <a:t>Sembilan Teori, Sembilan Putusan</a:t>
+              <a:t>Matriks Sembilan Teori</a:t>
             </a:r>
             <a:pPr indent="0" marL="0">
               <a:lnSpc>
@@ -17342,7 +17342,7 @@
                 <a:ea typeface="Calibri" pitchFamily="34" charset="-122"/>
                 <a:cs typeface="Calibri" pitchFamily="34" charset="-120"/>
               </a:rPr>
-              <a:t>Peran Teori Etika</a:t>
+              <a:t>Urgensi Teori Etika</a:t>
             </a:r>
             <a:endParaRPr lang="en-US" sz="1400" dirty="0"/>
           </a:p>
@@ -17381,7 +17381,7 @@
                 <a:ea typeface="Calibri" pitchFamily="34" charset="-122"/>
                 <a:cs typeface="Calibri" pitchFamily="34" charset="-120"/>
               </a:rPr>
-              <a:t>Kenapa keputusan bisnis butuh dasar penalaran</a:t>
+              <a:t>Dasar penalaran bagi keputusan bisnis</a:t>
             </a:r>
             <a:endParaRPr lang="en-US" sz="1150" dirty="0"/>
           </a:p>
@@ -17479,7 +17479,7 @@
                 <a:ea typeface="Calibri" pitchFamily="34" charset="-122"/>
                 <a:cs typeface="Calibri" pitchFamily="34" charset="-120"/>
               </a:rPr>
-              <a:t>Tiga Sikap Moral</a:t>
+              <a:t>Tiga Posisi Moral</a:t>
             </a:r>
             <a:endParaRPr lang="en-US" sz="1400" dirty="0"/>
           </a:p>
@@ -17518,7 +17518,7 @@
                 <a:ea typeface="Calibri" pitchFamily="34" charset="-122"/>
                 <a:cs typeface="Calibri" pitchFamily="34" charset="-120"/>
               </a:rPr>
-              <a:t>Absolutism, relativism, dan pluralism</a:t>
+              <a:t>Absolutism, relativism, pluralism</a:t>
             </a:r>
             <a:endParaRPr lang="en-US" sz="1150" dirty="0"/>
           </a:p>
@@ -17616,7 +17616,7 @@
                 <a:ea typeface="Calibri" pitchFamily="34" charset="-122"/>
                 <a:cs typeface="Calibri" pitchFamily="34" charset="-120"/>
               </a:rPr>
-              <a:t>Dua Keluarga Teori</a:t>
+              <a:t>Taksonomi Teori</a:t>
             </a:r>
             <a:endParaRPr lang="en-US" sz="1400" dirty="0"/>
           </a:p>
@@ -17890,7 +17890,7 @@
                 <a:ea typeface="Calibri" pitchFamily="34" charset="-122"/>
                 <a:cs typeface="Calibri" pitchFamily="34" charset="-120"/>
               </a:rPr>
-              <a:t>Menilai dari Akibat</a:t>
+              <a:t>Teori Consequentialist</a:t>
             </a:r>
             <a:endParaRPr lang="en-US" sz="1400" dirty="0"/>
           </a:p>
@@ -18027,7 +18027,7 @@
                 <a:ea typeface="Calibri" pitchFamily="34" charset="-122"/>
                 <a:cs typeface="Calibri" pitchFamily="34" charset="-120"/>
               </a:rPr>
-              <a:t>Menilai dari Prinsip</a:t>
+              <a:t>Teori Principle-based</a:t>
             </a:r>
             <a:endParaRPr lang="en-US" sz="1400" dirty="0"/>
           </a:p>
@@ -18164,7 +18164,7 @@
                 <a:ea typeface="Calibri" pitchFamily="34" charset="-122"/>
                 <a:cs typeface="Calibri" pitchFamily="34" charset="-120"/>
               </a:rPr>
-              <a:t>Enam Kritik</a:t>
+              <a:t>Kritik dan Keterbatasan</a:t>
             </a:r>
             <a:endParaRPr lang="en-US" sz="1400" dirty="0"/>
           </a:p>
@@ -18301,7 +18301,7 @@
                 <a:ea typeface="Calibri" pitchFamily="34" charset="-122"/>
                 <a:cs typeface="Calibri" pitchFamily="34" charset="-120"/>
               </a:rPr>
-              <a:t>Empat Alternatif</a:t>
+              <a:t>Perspektif Alternatif</a:t>
             </a:r>
             <a:endParaRPr lang="en-US" sz="1400" dirty="0"/>
           </a:p>
@@ -18701,7 +18701,7 @@
         <p:spPr>
           <a:xfrm>
             <a:off x="621792" y="457200"/>
-            <a:ext cx="962863" cy="283464"/>
+            <a:ext cx="1143914" cy="283464"/>
           </a:xfrm>
           <a:prstGeom prst="roundRect">
             <a:avLst>
@@ -18728,7 +18728,7 @@
         <p:spPr>
           <a:xfrm>
             <a:off x="621792" y="457200"/>
-            <a:ext cx="962863" cy="283464"/>
+            <a:ext cx="1143914" cy="283464"/>
           </a:xfrm>
           <a:prstGeom prst="rect">
             <a:avLst/>
@@ -18752,7 +18752,7 @@
                 <a:ea typeface="Calibri" pitchFamily="34" charset="-122"/>
                 <a:cs typeface="Calibri" pitchFamily="34" charset="-120"/>
               </a:rPr>
-              <a:t>DISKUSI</a:t>
+              <a:t>PENERAPAN</a:t>
             </a:r>
             <a:endParaRPr lang="en-US" sz="950" dirty="0"/>
           </a:p>
@@ -18766,7 +18766,7 @@
         </p:nvSpPr>
         <p:spPr>
           <a:xfrm>
-            <a:off x="1703527" y="457200"/>
+            <a:off x="1884578" y="457200"/>
             <a:ext cx="1143914" cy="283464"/>
           </a:xfrm>
           <a:prstGeom prst="roundRect">
@@ -18793,7 +18793,7 @@
         </p:nvSpPr>
         <p:spPr>
           <a:xfrm>
-            <a:off x="1703527" y="457200"/>
+            <a:off x="1884578" y="457200"/>
             <a:ext cx="1143914" cy="283464"/>
           </a:xfrm>
           <a:prstGeom prst="rect">
@@ -18899,7 +18899,7 @@
                 <a:ea typeface="Calibri" pitchFamily="34" charset="-122"/>
                 <a:cs typeface="Calibri" pitchFamily="34" charset="-120"/>
               </a:rPr>
-              <a:t>Empat Pertanyaan untuk Kelas</a:t>
+              <a:t>Agenda Diskusi</a:t>
             </a:r>
             <a:pPr indent="0" marL="0">
               <a:lnSpc>
@@ -18958,7 +18958,7 @@
                 <a:ea typeface="Calibri" pitchFamily="34" charset="-122"/>
                 <a:cs typeface="Calibri" pitchFamily="34" charset="-120"/>
               </a:rPr>
-              <a:t>Setiap pertanyaan menguji satu teori pada kasus yang sama.</a:t>
+              <a:t>Empat pertanyaan pemandu, masing-masing menguji satu teori.</a:t>
             </a:r>
             <a:endParaRPr lang="en-US" sz="1350" dirty="0"/>
           </a:p>
@@ -21266,7 +21266,7 @@
                 <a:ea typeface="Calibri" pitchFamily="34" charset="-122"/>
                 <a:cs typeface="Calibri" pitchFamily="34" charset="-120"/>
               </a:rPr>
-              <a:t>Etika Bisnis Butuh Dasar, Bukan Selera</a:t>
+              <a:t>Urgensi Teori Etika Normatif</a:t>
             </a:r>
             <a:pPr indent="0" marL="0">
               <a:lnSpc>
@@ -21450,7 +21450,7 @@
                 <a:ea typeface="Calibri" pitchFamily="34" charset="-122"/>
                 <a:cs typeface="Calibri" pitchFamily="34" charset="-120"/>
               </a:rPr>
-              <a:t>Konteksnya Lebih Rumit</a:t>
+              <a:t>Kompleksitas Konteks</a:t>
             </a:r>
             <a:endParaRPr lang="en-US" sz="1400" dirty="0"/>
           </a:p>
@@ -21617,7 +21617,7 @@
                 <a:ea typeface="Calibri" pitchFamily="34" charset="-122"/>
                 <a:cs typeface="Calibri" pitchFamily="34" charset="-120"/>
               </a:rPr>
-              <a:t>Keputusan Harus Dibela</a:t>
+              <a:t>Kewajiban Justifikasi</a:t>
             </a:r>
             <a:endParaRPr lang="en-US" sz="1400" dirty="0"/>
           </a:p>
@@ -21784,7 +21784,7 @@
                 <a:ea typeface="Calibri" pitchFamily="34" charset="-122"/>
                 <a:cs typeface="Calibri" pitchFamily="34" charset="-120"/>
               </a:rPr>
-              <a:t>Kritik Juga Butuh Dasar</a:t>
+              <a:t>Kritik Menuntut Landasan</a:t>
             </a:r>
             <a:endParaRPr lang="en-US" sz="1400" dirty="0"/>
           </a:p>
@@ -22214,7 +22214,7 @@
                 <a:ea typeface="Calibri" pitchFamily="34" charset="-122"/>
                 <a:cs typeface="Calibri" pitchFamily="34" charset="-120"/>
               </a:rPr>
-              <a:t>Tiga Sikap terhadap Kebenaran Moral</a:t>
+              <a:t>Absolutism, Relativism, Pluralism</a:t>
             </a:r>
             <a:pPr indent="0" marL="0">
               <a:lnSpc>
@@ -23226,7 +23226,7 @@
                 <a:ea typeface="Calibri" pitchFamily="34" charset="-122"/>
                 <a:cs typeface="Calibri" pitchFamily="34" charset="-120"/>
               </a:rPr>
-              <a:t>Dua Keluarga Besar Teori Barat Modern</a:t>
+              <a:t>Taksonomi Teori Barat Modern</a:t>
             </a:r>
             <a:pPr indent="0" marL="0">
               <a:lnSpc>
@@ -24108,7 +24108,7 @@
         <p:spPr>
           <a:xfrm>
             <a:off x="621792" y="457200"/>
-            <a:ext cx="1506017" cy="283464"/>
+            <a:ext cx="1596542" cy="283464"/>
           </a:xfrm>
           <a:prstGeom prst="roundRect">
             <a:avLst>
@@ -24135,7 +24135,7 @@
         <p:spPr>
           <a:xfrm>
             <a:off x="621792" y="457200"/>
-            <a:ext cx="1506017" cy="283464"/>
+            <a:ext cx="1596542" cy="283464"/>
           </a:xfrm>
           <a:prstGeom prst="rect">
             <a:avLst/>
@@ -24159,7 +24159,7 @@
                 <a:ea typeface="Calibri" pitchFamily="34" charset="-122"/>
                 <a:cs typeface="Calibri" pitchFamily="34" charset="-120"/>
               </a:rPr>
-              <a:t>KASUS PENGUJI</a:t>
+              <a:t>PRODUCING TOYS</a:t>
             </a:r>
             <a:endParaRPr lang="en-US" sz="950" dirty="0"/>
           </a:p>
@@ -24173,7 +24173,7 @@
         </p:nvSpPr>
         <p:spPr>
           <a:xfrm>
-            <a:off x="2246681" y="457200"/>
+            <a:off x="2337206" y="457200"/>
             <a:ext cx="1234440" cy="283464"/>
           </a:xfrm>
           <a:prstGeom prst="roundRect">
@@ -24200,7 +24200,7 @@
         </p:nvSpPr>
         <p:spPr>
           <a:xfrm>
-            <a:off x="2246681" y="457200"/>
+            <a:off x="2337206" y="457200"/>
             <a:ext cx="1234440" cy="283464"/>
           </a:xfrm>
           <a:prstGeom prst="rect">
@@ -24306,7 +24306,7 @@
                 <a:ea typeface="Calibri" pitchFamily="34" charset="-122"/>
                 <a:cs typeface="Calibri" pitchFamily="34" charset="-120"/>
               </a:rPr>
-              <a:t>Ethical Dilemma 3: Producing Toys</a:t>
+              <a:t>Ethical Dilemma 3</a:t>
             </a:r>
             <a:pPr indent="0" marL="0">
               <a:lnSpc>
@@ -25487,7 +25487,7 @@
                 <a:ea typeface="Calibri" pitchFamily="34" charset="-122"/>
                 <a:cs typeface="Calibri" pitchFamily="34" charset="-120"/>
               </a:rPr>
-              <a:t>Bukan Serakah Sesaat</a:t>
+              <a:t>Horizon Jangka Panjang</a:t>
             </a:r>
             <a:endParaRPr lang="en-US" sz="1400" dirty="0"/>
           </a:p>
@@ -25654,7 +25654,7 @@
                 <a:ea typeface="Calibri" pitchFamily="34" charset="-122"/>
                 <a:cs typeface="Calibri" pitchFamily="34" charset="-120"/>
               </a:rPr>
-              <a:t>Batasnya: Market Failure</a:t>
+              <a:t>Batas: Market Failure</a:t>
             </a:r>
             <a:endParaRPr lang="en-US" sz="1400" dirty="0"/>
           </a:p>
@@ -26991,7 +26991,7 @@
         <p:spPr>
           <a:xfrm>
             <a:off x="1794053" y="457200"/>
-            <a:ext cx="1415491" cy="283464"/>
+            <a:ext cx="1687068" cy="283464"/>
           </a:xfrm>
           <a:prstGeom prst="roundRect">
             <a:avLst>
@@ -27018,7 +27018,7 @@
         <p:spPr>
           <a:xfrm>
             <a:off x="1794053" y="457200"/>
-            <a:ext cx="1415491" cy="283464"/>
+            <a:ext cx="1687068" cy="283464"/>
           </a:xfrm>
           <a:prstGeom prst="rect">
             <a:avLst/>
@@ -27042,7 +27042,7 @@
                 <a:ea typeface="Calibri" pitchFamily="34" charset="-122"/>
                 <a:cs typeface="Calibri" pitchFamily="34" charset="-120"/>
               </a:rPr>
-              <a:t>KETERBATASAN</a:t>
+              <a:t>KRITIK INTERNAL</a:t>
             </a:r>
             <a:endParaRPr lang="en-US" sz="950" dirty="0"/>
           </a:p>
@@ -27123,7 +27123,7 @@
                 <a:ea typeface="Calibri" pitchFamily="34" charset="-122"/>
                 <a:cs typeface="Calibri" pitchFamily="34" charset="-120"/>
               </a:rPr>
-              <a:t>Empat Masalah, Lalu Dua Jenis</a:t>
+              <a:t>Keterbatasan Utilitarianism</a:t>
             </a:r>
             <a:pPr indent="0" marL="0">
               <a:lnSpc>
@@ -27182,7 +27182,7 @@
                 <a:ea typeface="Calibri" pitchFamily="34" charset="-122"/>
                 <a:cs typeface="Calibri" pitchFamily="34" charset="-120"/>
               </a:rPr>
-              <a:t>Penyempurnaan Mill memecah utilitarianism menjadi dua cara menilai yang berlawanan.</a:t>
+              <a:t>Empat masalah pokok, lalu penyempurnaan Mill menjadi dua jenis penilaian.</a:t>
             </a:r>
             <a:endParaRPr lang="en-US" sz="1350" dirty="0"/>
           </a:p>

</xml_diff>